<commit_message>
mini update of the slides
</commit_message>
<xml_diff>
--- a/workshops/2026-10-25-agifors-annual-symposium/Zenteno Smith - 2026 - Rethinking the embedded OR team a a specialized software team.pptx
+++ b/workshops/2026-10-25-agifors-annual-symposium/Zenteno Smith - 2026 - Rethinking the embedded OR team a a specialized software team.pptx
@@ -218,7 +218,7 @@
           <a:p>
             <a:fld id="{A9508B69-4B04-442E-A249-3DCED873EEFA}" type="datetimeFigureOut">
               <a:rPr lang="en-US" smtClean="0"/>
-              <a:t>9/24/2026</a:t>
+              <a:t>10/17/2026</a:t>
             </a:fld>
             <a:endParaRPr lang="en-US"/>
           </a:p>
@@ -616,6 +616,78 @@
               <a:t>SEFOP exists so OR teams do not have to rediscover these practices independently.</a:t>
             </a:r>
           </a:p>
+          <a:p>
+            <a:pPr marL="171450" indent="-171450" algn="l">
+              <a:spcAft>
+                <a:spcPts val="400"/>
+              </a:spcAft>
+              <a:buFontTx/>
+              <a:buChar char="-"/>
+            </a:pPr>
+            <a:r>
+              <a:rPr lang="en-US" sz="1200" b="0" dirty="0">
+                <a:solidFill>
+                  <a:srgbClr val="64748B"/>
+                </a:solidFill>
+                <a:latin typeface="+mn-lt"/>
+              </a:rPr>
+              <a:t>Train: teach unit testing to scientists, integration testing and testing optimization models</a:t>
+            </a:r>
+          </a:p>
+          <a:p>
+            <a:pPr marL="171450" indent="-171450" algn="l">
+              <a:spcAft>
+                <a:spcPts val="400"/>
+              </a:spcAft>
+              <a:buFontTx/>
+              <a:buChar char="-"/>
+            </a:pPr>
+            <a:r>
+              <a:rPr lang="en-US" sz="1200" b="0" dirty="0">
+                <a:solidFill>
+                  <a:srgbClr val="64748B"/>
+                </a:solidFill>
+                <a:latin typeface="+mn-lt"/>
+              </a:rPr>
+              <a:t>Lead: how to maintain a software quality practice in your scientific team?</a:t>
+            </a:r>
+          </a:p>
+          <a:p>
+            <a:pPr marL="171450" indent="-171450" algn="l">
+              <a:spcAft>
+                <a:spcPts val="400"/>
+              </a:spcAft>
+              <a:buFontTx/>
+              <a:buChar char="-"/>
+            </a:pPr>
+            <a:r>
+              <a:rPr lang="en-US" sz="1200" b="0" dirty="0">
+                <a:solidFill>
+                  <a:srgbClr val="64748B"/>
+                </a:solidFill>
+                <a:latin typeface="+mn-lt"/>
+              </a:rPr>
+              <a:t>Deliver: templates and design examples to help you start</a:t>
+            </a:r>
+          </a:p>
+          <a:p>
+            <a:pPr marL="171450" indent="-171450" algn="l">
+              <a:spcAft>
+                <a:spcPts val="400"/>
+              </a:spcAft>
+              <a:buFontTx/>
+              <a:buChar char="-"/>
+            </a:pPr>
+            <a:r>
+              <a:rPr lang="en-US" sz="1200" b="0" dirty="0">
+                <a:solidFill>
+                  <a:srgbClr val="64748B"/>
+                </a:solidFill>
+                <a:latin typeface="+mn-lt"/>
+              </a:rPr>
+              <a:t>Go agentic: agentic skills that could be useful for you</a:t>
+            </a:r>
+          </a:p>
         </p:txBody>
       </p:sp>
       <p:sp>
@@ -1699,7 +1771,7 @@
           <a:p>
             <a:fld id="{8967FF14-F878-45E8-AFB4-46D953F41C81}" type="datetime1">
               <a:rPr lang="en-US" smtClean="0"/>
-              <a:t>9/24/2026</a:t>
+              <a:t>10/17/2026</a:t>
             </a:fld>
             <a:endParaRPr lang="en-US"/>
           </a:p>
@@ -1867,7 +1939,7 @@
           <a:p>
             <a:fld id="{44869591-628F-4BAB-AD9F-697EBD829841}" type="datetime1">
               <a:rPr lang="en-US" smtClean="0"/>
-              <a:t>9/24/2026</a:t>
+              <a:t>10/17/2026</a:t>
             </a:fld>
             <a:endParaRPr lang="en-US"/>
           </a:p>
@@ -2045,7 +2117,7 @@
           <a:p>
             <a:fld id="{76AEFADA-DB7A-4DBF-B5C8-201C4683F8E6}" type="datetime1">
               <a:rPr lang="en-US" smtClean="0"/>
-              <a:t>9/24/2026</a:t>
+              <a:t>10/17/2026</a:t>
             </a:fld>
             <a:endParaRPr lang="en-US"/>
           </a:p>
@@ -2213,7 +2285,7 @@
           <a:p>
             <a:fld id="{BE3B6F46-0C3C-4175-8B43-348544656D81}" type="datetime1">
               <a:rPr lang="en-US" smtClean="0"/>
-              <a:t>9/24/2026</a:t>
+              <a:t>10/17/2026</a:t>
             </a:fld>
             <a:endParaRPr lang="en-US"/>
           </a:p>
@@ -2458,7 +2530,7 @@
           <a:p>
             <a:fld id="{AA346EC6-7322-4DBC-84C7-E11D30942555}" type="datetime1">
               <a:rPr lang="en-US" smtClean="0"/>
-              <a:t>9/24/2026</a:t>
+              <a:t>10/17/2026</a:t>
             </a:fld>
             <a:endParaRPr lang="en-US"/>
           </a:p>
@@ -2743,7 +2815,7 @@
           <a:p>
             <a:fld id="{22848B31-6056-4B86-B43A-9DBD0BACB6B8}" type="datetime1">
               <a:rPr lang="en-US" smtClean="0"/>
-              <a:t>9/24/2026</a:t>
+              <a:t>10/17/2026</a:t>
             </a:fld>
             <a:endParaRPr lang="en-US"/>
           </a:p>
@@ -3162,7 +3234,7 @@
           <a:p>
             <a:fld id="{5E9A4DAE-E39A-4AB4-9A37-8C4CE854B5ED}" type="datetime1">
               <a:rPr lang="en-US" smtClean="0"/>
-              <a:t>9/24/2026</a:t>
+              <a:t>10/17/2026</a:t>
             </a:fld>
             <a:endParaRPr lang="en-US"/>
           </a:p>
@@ -3279,7 +3351,7 @@
           <a:p>
             <a:fld id="{CCC0320F-0C3E-448D-9224-8CF88A1B4ED1}" type="datetime1">
               <a:rPr lang="en-US" smtClean="0"/>
-              <a:t>9/24/2026</a:t>
+              <a:t>10/17/2026</a:t>
             </a:fld>
             <a:endParaRPr lang="en-US"/>
           </a:p>
@@ -3374,7 +3446,7 @@
           <a:p>
             <a:fld id="{A2C46C6B-8CC5-4835-9317-0254AF58E7FA}" type="datetime1">
               <a:rPr lang="en-US" smtClean="0"/>
-              <a:t>9/24/2026</a:t>
+              <a:t>10/17/2026</a:t>
             </a:fld>
             <a:endParaRPr lang="en-US"/>
           </a:p>
@@ -3654,7 +3726,7 @@
           <a:p>
             <a:fld id="{AC12DB2F-C7F6-4FDA-BA62-32815EE05B27}" type="datetime1">
               <a:rPr lang="en-US" smtClean="0"/>
-              <a:t>9/24/2026</a:t>
+              <a:t>10/17/2026</a:t>
             </a:fld>
             <a:endParaRPr lang="en-US"/>
           </a:p>
@@ -3906,7 +3978,7 @@
           <a:p>
             <a:fld id="{5A7BFFA9-8A0F-4C1F-BDA9-E4A846D0523F}" type="datetime1">
               <a:rPr lang="en-US" smtClean="0"/>
-              <a:t>9/24/2026</a:t>
+              <a:t>10/17/2026</a:t>
             </a:fld>
             <a:endParaRPr lang="en-US"/>
           </a:p>
@@ -4117,7 +4189,7 @@
           <a:p>
             <a:fld id="{AE506CE3-984D-4D4B-A976-00BBA5D668A5}" type="datetime1">
               <a:rPr lang="en-US" smtClean="0"/>
-              <a:t>9/24/2026</a:t>
+              <a:t>10/17/2026</a:t>
             </a:fld>
             <a:endParaRPr lang="en-US"/>
           </a:p>
@@ -6301,53 +6373,14 @@
                 </a:solidFill>
                 <a:latin typeface="Aptos"/>
               </a:rPr>
-              <a:t>delivers a recurring decision (</a:t>
-            </a:r>
-            <a:r>
-              <a:rPr sz="2000" b="0" dirty="0">
-                <a:solidFill>
-                  <a:srgbClr val="0F2343"/>
-                </a:solidFill>
-                <a:latin typeface="Aptos"/>
-              </a:rPr>
-              <a:t>and someone </a:t>
-            </a:r>
-            <a:r>
-              <a:rPr lang="en-US" sz="2000" b="0" dirty="0">
-                <a:solidFill>
-                  <a:srgbClr val="0F2343"/>
-                </a:solidFill>
-                <a:latin typeface="Aptos"/>
-              </a:rPr>
-              <a:t>must</a:t>
-            </a:r>
-            <a:r>
-              <a:rPr sz="2000" b="0" dirty="0">
-                <a:solidFill>
-                  <a:srgbClr val="0F2343"/>
-                </a:solidFill>
-                <a:latin typeface="Aptos"/>
-              </a:rPr>
-              <a:t> own it</a:t>
-            </a:r>
-            <a:r>
-              <a:rPr lang="en-US" sz="2000" b="0" dirty="0">
-                <a:solidFill>
-                  <a:srgbClr val="0F2343"/>
-                </a:solidFill>
-                <a:latin typeface="Aptos"/>
-              </a:rPr>
-              <a:t>)</a:t>
-            </a:r>
-            <a:r>
-              <a:rPr lang="en-US" sz="2000" dirty="0">
-                <a:solidFill>
-                  <a:srgbClr val="0F2343"/>
-                </a:solidFill>
-                <a:latin typeface="Aptos"/>
-              </a:rPr>
-              <a:t>.</a:t>
-            </a:r>
+              <a:t>delivers a recurring decision.</a:t>
+            </a:r>
+            <a:endParaRPr lang="en-US" sz="2000" dirty="0">
+              <a:solidFill>
+                <a:srgbClr val="0F2343"/>
+              </a:solidFill>
+              <a:latin typeface="Aptos"/>
+            </a:endParaRPr>
           </a:p>
         </p:txBody>
       </p:sp>
@@ -8573,7 +8606,7 @@
                 <a:latin typeface="Aptos"/>
                 <a:sym typeface="Wingdings" panose="05000000000000000000" pitchFamily="2" charset="2"/>
               </a:rPr>
-              <a:t>DSS has unique challenges deriving from the mixture of applied mathematics and SE.</a:t>
+              <a:t>DSS has unique challenges deriving from the fusion of applied mathematics and SE.</a:t>
             </a:r>
           </a:p>
         </p:txBody>
@@ -8687,6 +8720,198 @@
               <a:t>3</a:t>
             </a:fld>
             <a:endParaRPr lang="en-US"/>
+          </a:p>
+        </p:txBody>
+      </p:sp>
+      <p:sp>
+        <p:nvSpPr>
+          <p:cNvPr id="7" name="Speech Bubble: Rectangle 6">
+            <a:extLst>
+              <a:ext uri="{FF2B5EF4-FFF2-40B4-BE49-F238E27FC236}">
+                <a16:creationId xmlns:a16="http://schemas.microsoft.com/office/drawing/2014/main" id="{99BB9CE4-44CD-0AAB-6DA8-31404CC71AFE}"/>
+              </a:ext>
+            </a:extLst>
+          </p:cNvPr>
+          <p:cNvSpPr/>
+          <p:nvPr/>
+        </p:nvSpPr>
+        <p:spPr>
+          <a:xfrm>
+            <a:off x="2917539" y="1720142"/>
+            <a:ext cx="5023297" cy="2662201"/>
+          </a:xfrm>
+          <a:prstGeom prst="wedgeRectCallout">
+            <a:avLst>
+              <a:gd name="adj1" fmla="val -59611"/>
+              <a:gd name="adj2" fmla="val 17830"/>
+            </a:avLst>
+          </a:prstGeom>
+          <a:solidFill>
+            <a:schemeClr val="bg1">
+              <a:lumMod val="95000"/>
+            </a:schemeClr>
+          </a:solidFill>
+          <a:ln>
+            <a:solidFill>
+              <a:schemeClr val="tx1"/>
+            </a:solidFill>
+          </a:ln>
+        </p:spPr>
+        <p:style>
+          <a:lnRef idx="1">
+            <a:schemeClr val="accent1"/>
+          </a:lnRef>
+          <a:fillRef idx="3">
+            <a:schemeClr val="accent1"/>
+          </a:fillRef>
+          <a:effectRef idx="2">
+            <a:schemeClr val="accent1"/>
+          </a:effectRef>
+          <a:fontRef idx="minor">
+            <a:schemeClr val="lt1"/>
+          </a:fontRef>
+        </p:style>
+        <p:txBody>
+          <a:bodyPr rtlCol="0" anchor="t"/>
+          <a:lstStyle/>
+          <a:p>
+            <a:pPr>
+              <a:lnSpc>
+                <a:spcPct val="150000"/>
+              </a:lnSpc>
+            </a:pPr>
+            <a:r>
+              <a:rPr lang="en-US" dirty="0">
+                <a:solidFill>
+                  <a:schemeClr val="tx1"/>
+                </a:solidFill>
+                <a:latin typeface="Aptos" panose="020B0004020202020204" pitchFamily="34" charset="0"/>
+              </a:rPr>
+              <a:t>Some examples:</a:t>
+            </a:r>
+          </a:p>
+          <a:p>
+            <a:pPr marL="285750" indent="-285750">
+              <a:lnSpc>
+                <a:spcPct val="150000"/>
+              </a:lnSpc>
+              <a:buFont typeface="Arial" panose="020B0604020202020204" pitchFamily="34" charset="0"/>
+              <a:buChar char="•"/>
+            </a:pPr>
+            <a:r>
+              <a:rPr lang="en-US" dirty="0">
+                <a:solidFill>
+                  <a:schemeClr val="tx1"/>
+                </a:solidFill>
+                <a:latin typeface="Aptos" panose="020B0004020202020204" pitchFamily="34" charset="0"/>
+              </a:rPr>
+              <a:t>No version control</a:t>
+            </a:r>
+          </a:p>
+          <a:p>
+            <a:pPr marL="285750" indent="-285750">
+              <a:lnSpc>
+                <a:spcPct val="150000"/>
+              </a:lnSpc>
+              <a:buFont typeface="Arial" panose="020B0604020202020204" pitchFamily="34" charset="0"/>
+              <a:buChar char="•"/>
+            </a:pPr>
+            <a:r>
+              <a:rPr lang="en-US" dirty="0">
+                <a:solidFill>
+                  <a:schemeClr val="tx1"/>
+                </a:solidFill>
+                <a:latin typeface="Aptos" panose="020B0004020202020204" pitchFamily="34" charset="0"/>
+              </a:rPr>
+              <a:t>Lack of automated testing</a:t>
+            </a:r>
+          </a:p>
+          <a:p>
+            <a:pPr marL="285750" indent="-285750">
+              <a:lnSpc>
+                <a:spcPct val="150000"/>
+              </a:lnSpc>
+              <a:buFont typeface="Arial" panose="020B0604020202020204" pitchFamily="34" charset="0"/>
+              <a:buChar char="•"/>
+            </a:pPr>
+            <a:r>
+              <a:rPr lang="en-US" dirty="0">
+                <a:solidFill>
+                  <a:schemeClr val="tx1"/>
+                </a:solidFill>
+                <a:latin typeface="Aptos" panose="020B0004020202020204" pitchFamily="34" charset="0"/>
+              </a:rPr>
+              <a:t>Manual processes to make the system work.</a:t>
+            </a:r>
+          </a:p>
+          <a:p>
+            <a:pPr marL="285750" indent="-285750">
+              <a:lnSpc>
+                <a:spcPct val="150000"/>
+              </a:lnSpc>
+              <a:buFont typeface="Arial" panose="020B0604020202020204" pitchFamily="34" charset="0"/>
+              <a:buChar char="•"/>
+            </a:pPr>
+            <a:r>
+              <a:rPr lang="en-US" dirty="0">
+                <a:solidFill>
+                  <a:schemeClr val="tx1"/>
+                </a:solidFill>
+                <a:latin typeface="Aptos" panose="020B0004020202020204" pitchFamily="34" charset="0"/>
+              </a:rPr>
+              <a:t>Usage of </a:t>
+            </a:r>
+            <a:r>
+              <a:rPr lang="en-US" dirty="0" err="1">
+                <a:solidFill>
+                  <a:schemeClr val="tx1"/>
+                </a:solidFill>
+                <a:latin typeface="Aptos" panose="020B0004020202020204" pitchFamily="34" charset="0"/>
+              </a:rPr>
+              <a:t>jupyter</a:t>
+            </a:r>
+            <a:r>
+              <a:rPr lang="en-US" dirty="0">
+                <a:solidFill>
+                  <a:schemeClr val="tx1"/>
+                </a:solidFill>
+                <a:latin typeface="Aptos" panose="020B0004020202020204" pitchFamily="34" charset="0"/>
+              </a:rPr>
+              <a:t> notebooks in production.</a:t>
+            </a:r>
+          </a:p>
+          <a:p>
+            <a:pPr marL="285750" indent="-285750">
+              <a:lnSpc>
+                <a:spcPct val="150000"/>
+              </a:lnSpc>
+              <a:buFont typeface="Arial" panose="020B0604020202020204" pitchFamily="34" charset="0"/>
+              <a:buChar char="•"/>
+            </a:pPr>
+            <a:r>
+              <a:rPr lang="en-US" dirty="0">
+                <a:solidFill>
+                  <a:schemeClr val="tx1"/>
+                </a:solidFill>
+                <a:latin typeface="Aptos" panose="020B0004020202020204" pitchFamily="34" charset="0"/>
+              </a:rPr>
+              <a:t>Unclear software design.</a:t>
+            </a:r>
+          </a:p>
+          <a:p>
+            <a:pPr marL="285750" indent="-285750">
+              <a:lnSpc>
+                <a:spcPct val="150000"/>
+              </a:lnSpc>
+              <a:buFont typeface="Arial" panose="020B0604020202020204" pitchFamily="34" charset="0"/>
+              <a:buChar char="•"/>
+            </a:pPr>
+            <a:endParaRPr lang="en-US" dirty="0">
+              <a:solidFill>
+                <a:schemeClr val="tx1"/>
+              </a:solidFill>
+              <a:latin typeface="Aptos" panose="020B0004020202020204" pitchFamily="34" charset="0"/>
+            </a:endParaRPr>
           </a:p>
         </p:txBody>
       </p:sp>
@@ -8806,7 +9031,7 @@
                                           </p:stCondLst>
                                         </p:cTn>
                                         <p:tgtEl>
-                                          <p:spTgt spid="88"/>
+                                          <p:spTgt spid="7"/>
                                         </p:tgtEl>
                                         <p:attrNameLst>
                                           <p:attrName>style.visibility</p:attrName>
@@ -8838,7 +9063,7 @@
                             </p:stCondLst>
                             <p:childTnLst>
                               <p:par>
-                                <p:cTn id="15" presetID="1" presetClass="entr" presetSubtype="0" fill="hold" grpId="0" nodeType="clickEffect">
+                                <p:cTn id="15" presetID="1" presetClass="exit" presetSubtype="0" fill="hold" grpId="1" nodeType="clickEffect">
                                   <p:stCondLst>
                                     <p:cond delay="0"/>
                                   </p:stCondLst>
@@ -8851,14 +9076,14 @@
                                           </p:stCondLst>
                                         </p:cTn>
                                         <p:tgtEl>
-                                          <p:spTgt spid="90"/>
+                                          <p:spTgt spid="7"/>
                                         </p:tgtEl>
                                         <p:attrNameLst>
                                           <p:attrName>style.visibility</p:attrName>
                                         </p:attrNameLst>
                                       </p:cBhvr>
                                       <p:to>
-                                        <p:strVal val="visible"/>
+                                        <p:strVal val="hidden"/>
                                       </p:to>
                                     </p:set>
                                   </p:childTnLst>
@@ -8896,7 +9121,7 @@
                                           </p:stCondLst>
                                         </p:cTn>
                                         <p:tgtEl>
-                                          <p:spTgt spid="92"/>
+                                          <p:spTgt spid="88"/>
                                         </p:tgtEl>
                                         <p:attrNameLst>
                                           <p:attrName>style.visibility</p:attrName>
@@ -8936,6 +9161,96 @@
                                     <p:set>
                                       <p:cBhvr>
                                         <p:cTn id="24" dur="1" fill="hold">
+                                          <p:stCondLst>
+                                            <p:cond delay="0"/>
+                                          </p:stCondLst>
+                                        </p:cTn>
+                                        <p:tgtEl>
+                                          <p:spTgt spid="90"/>
+                                        </p:tgtEl>
+                                        <p:attrNameLst>
+                                          <p:attrName>style.visibility</p:attrName>
+                                        </p:attrNameLst>
+                                      </p:cBhvr>
+                                      <p:to>
+                                        <p:strVal val="visible"/>
+                                      </p:to>
+                                    </p:set>
+                                  </p:childTnLst>
+                                </p:cTn>
+                              </p:par>
+                            </p:childTnLst>
+                          </p:cTn>
+                        </p:par>
+                      </p:childTnLst>
+                    </p:cTn>
+                  </p:par>
+                  <p:par>
+                    <p:cTn id="25" fill="hold">
+                      <p:stCondLst>
+                        <p:cond delay="indefinite"/>
+                      </p:stCondLst>
+                      <p:childTnLst>
+                        <p:par>
+                          <p:cTn id="26" fill="hold">
+                            <p:stCondLst>
+                              <p:cond delay="0"/>
+                            </p:stCondLst>
+                            <p:childTnLst>
+                              <p:par>
+                                <p:cTn id="27" presetID="1" presetClass="entr" presetSubtype="0" fill="hold" grpId="0" nodeType="clickEffect">
+                                  <p:stCondLst>
+                                    <p:cond delay="0"/>
+                                  </p:stCondLst>
+                                  <p:childTnLst>
+                                    <p:set>
+                                      <p:cBhvr>
+                                        <p:cTn id="28" dur="1" fill="hold">
+                                          <p:stCondLst>
+                                            <p:cond delay="0"/>
+                                          </p:stCondLst>
+                                        </p:cTn>
+                                        <p:tgtEl>
+                                          <p:spTgt spid="92"/>
+                                        </p:tgtEl>
+                                        <p:attrNameLst>
+                                          <p:attrName>style.visibility</p:attrName>
+                                        </p:attrNameLst>
+                                      </p:cBhvr>
+                                      <p:to>
+                                        <p:strVal val="visible"/>
+                                      </p:to>
+                                    </p:set>
+                                  </p:childTnLst>
+                                </p:cTn>
+                              </p:par>
+                            </p:childTnLst>
+                          </p:cTn>
+                        </p:par>
+                      </p:childTnLst>
+                    </p:cTn>
+                  </p:par>
+                  <p:par>
+                    <p:cTn id="29" fill="hold">
+                      <p:stCondLst>
+                        <p:cond delay="indefinite"/>
+                      </p:stCondLst>
+                      <p:childTnLst>
+                        <p:par>
+                          <p:cTn id="30" fill="hold">
+                            <p:stCondLst>
+                              <p:cond delay="0"/>
+                            </p:stCondLst>
+                            <p:childTnLst>
+                              <p:par>
+                                <p:cTn id="31" presetID="1" presetClass="entr" presetSubtype="0" fill="hold" grpId="0" nodeType="clickEffect">
+                                  <p:stCondLst>
+                                    <p:cond delay="0"/>
+                                  </p:stCondLst>
+                                  <p:childTnLst>
+                                    <p:set>
+                                      <p:cBhvr>
+                                        <p:cTn id="32" dur="1" fill="hold">
                                           <p:stCondLst>
                                             <p:cond delay="0"/>
                                           </p:stCondLst>
@@ -8986,6 +9301,8 @@
       <p:bldP spid="90" grpId="0"/>
       <p:bldP spid="92" grpId="0"/>
       <p:bldP spid="5" grpId="0"/>
+      <p:bldP spid="7" grpId="0" animBg="1"/>
+      <p:bldP spid="7" grpId="1" animBg="1"/>
     </p:bldLst>
   </p:timing>
 </p:sld>
@@ -10545,7 +10862,7 @@
                 <a:latin typeface="Aptos"/>
                 <a:sym typeface="Wingdings" panose="05000000000000000000" pitchFamily="2" charset="2"/>
               </a:rPr>
-              <a:t> to tackle problems unrelated to OR: design a database, data, deployments.</a:t>
+              <a:t> to tackle problems agnostic to OR: design a database, data, deployments.</a:t>
             </a:r>
             <a:endParaRPr sz="1600" dirty="0">
               <a:solidFill>
@@ -13306,6 +13623,53 @@
               <a:t>7</a:t>
             </a:fld>
             <a:endParaRPr lang="en-US"/>
+          </a:p>
+        </p:txBody>
+      </p:sp>
+      <p:sp>
+        <p:nvSpPr>
+          <p:cNvPr id="5" name="TextBox 4">
+            <a:extLst>
+              <a:ext uri="{FF2B5EF4-FFF2-40B4-BE49-F238E27FC236}">
+                <a16:creationId xmlns:a16="http://schemas.microsoft.com/office/drawing/2014/main" id="{C2F00BEA-BA70-D137-11DA-9B578A1356DB}"/>
+              </a:ext>
+            </a:extLst>
+          </p:cNvPr>
+          <p:cNvSpPr txBox="1"/>
+          <p:nvPr/>
+        </p:nvSpPr>
+        <p:spPr>
+          <a:xfrm>
+            <a:off x="292843" y="6454629"/>
+            <a:ext cx="11329984" cy="338554"/>
+          </a:xfrm>
+          <a:prstGeom prst="rect">
+            <a:avLst/>
+          </a:prstGeom>
+          <a:noFill/>
+        </p:spPr>
+        <p:txBody>
+          <a:bodyPr wrap="square" tIns="0" rIns="45720" bIns="0">
+            <a:spAutoFit/>
+          </a:bodyPr>
+          <a:lstStyle/>
+          <a:p>
+            <a:pPr algn="l"/>
+            <a:r>
+              <a:rPr lang="en-US" sz="1100" dirty="0">
+                <a:solidFill>
+                  <a:srgbClr val="0F2343"/>
+                </a:solidFill>
+                <a:latin typeface="Aptos"/>
+              </a:rPr>
+              <a:t>* Data is confidential. At a high-level: throughput measured as commits to main branch per person per weak. Software quality measured as unit-testing coverage at line level, and code smells indicated by a static-code analysis tool.</a:t>
+            </a:r>
+            <a:endParaRPr sz="1100" dirty="0">
+              <a:solidFill>
+                <a:srgbClr val="0F2343"/>
+              </a:solidFill>
+              <a:latin typeface="Aptos"/>
+            </a:endParaRPr>
           </a:p>
         </p:txBody>
       </p:sp>

</xml_diff>